<commit_message>
Separate grid into animated overlay with stronger visibility
- Grid is now a separate oversized PNG (20% larger) layered on top
- Grid opacity increased from 5% to 9% for better visibility
- Added diagonal drift motion-path animation (8s, infinite, auto-reverse)
- Base bg image kept separate (dark + green blob)

https://claude.ai/code/session_01Eg4uVCjZGUEPVWg9afrsT1
</commit_message>
<xml_diff>
--- a/presentation.pptx
+++ b/presentation.pptx
@@ -3129,9 +3129,33 @@
           </a:prstGeom>
         </p:spPr>
       </p:pic>
-      <p:sp>
-        <p:nvSpPr>
-          <p:cNvPr id="3" name="TextBox 2"/>
+      <p:pic>
+        <p:nvPicPr>
+          <p:cNvPr id="3" name="Picture 2" descr="_slide_grid.png"/>
+          <p:cNvPicPr>
+            <a:picLocks noChangeAspect="1"/>
+          </p:cNvPicPr>
+          <p:nvPr/>
+        </p:nvPicPr>
+        <p:blipFill>
+          <a:blip r:embed="rId3"/>
+          <a:stretch>
+            <a:fillRect/>
+          </a:stretch>
+        </p:blipFill>
+        <p:spPr>
+          <a:xfrm>
+            <a:off x="-685800" y="-685800"/>
+            <a:ext cx="13563295" cy="8229600"/>
+          </a:xfrm>
+          <a:prstGeom prst="rect">
+            <a:avLst/>
+          </a:prstGeom>
+        </p:spPr>
+      </p:pic>
+      <p:sp>
+        <p:nvSpPr>
+          <p:cNvPr id="6" name="TextBox 5"/>
           <p:cNvSpPr txBox="1"/>
           <p:nvPr/>
         </p:nvSpPr>
@@ -3166,7 +3190,7 @@
       </p:sp>
       <p:sp>
         <p:nvSpPr>
-          <p:cNvPr id="4" name="TextBox 3"/>
+          <p:cNvPr id="7" name="TextBox 6"/>
           <p:cNvSpPr txBox="1"/>
           <p:nvPr/>
         </p:nvSpPr>
@@ -3201,7 +3225,7 @@
       </p:sp>
       <p:sp>
         <p:nvSpPr>
-          <p:cNvPr id="5" name="TextBox 4"/>
+          <p:cNvPr id="8" name="TextBox 7"/>
           <p:cNvSpPr txBox="1"/>
           <p:nvPr/>
         </p:nvSpPr>
@@ -3259,6 +3283,66 @@
   <p:clrMapOvr>
     <a:masterClrMapping/>
   </p:clrMapOvr>
+  <p:timing>
+    <p:tnLst>
+      <p:par>
+        <p:cTn id="1" dur="indefinite" restart="never" nodeType="tmRoot">
+          <p:childTnLst>
+            <p:seq concurrent="1" nextAc="seek">
+              <p:cTn id="2" dur="indefinite" nodeType="mainSeq">
+                <p:childTnLst>
+                  <p:par>
+                    <p:cTn id="3" fill="hold">
+                      <p:stCondLst>
+                        <p:cond delay="0"/>
+                      </p:stCondLst>
+                      <p:childTnLst>
+                        <p:par>
+                          <p:cTn id="4" fill="hold">
+                            <p:stCondLst>
+                              <p:cond delay="0"/>
+                            </p:stCondLst>
+                            <p:childTnLst>
+                              <p:animMotion origin="layout" path="M 0 0 L 0.03 0.03" pathEditMode="relative" ptsTypes="AA" rAng="0">
+                                <p:cBhvr>
+                                  <p:cTn id="5" dur="8000" repeatCount="indefinite" autoRev="1" fill="hold">
+                                    <p:stCondLst>
+                                      <p:cond delay="0"/>
+                                    </p:stCondLst>
+                                  </p:cTn>
+                                  <p:tgtEl>
+                                    <p:spTgt spid="3"/>
+                                  </p:tgtEl>
+                                </p:cBhvr>
+                              </p:animMotion>
+                            </p:childTnLst>
+                          </p:cTn>
+                        </p:par>
+                      </p:childTnLst>
+                    </p:cTn>
+                  </p:par>
+                </p:childTnLst>
+              </p:cTn>
+              <p:prevCondLst>
+                <p:cond evt="onPrev" delay="0">
+                  <p:tgtEl>
+                    <p:sldTgt/>
+                  </p:tgtEl>
+                </p:cond>
+              </p:prevCondLst>
+              <p:nextCondLst>
+                <p:cond evt="onNext" delay="0">
+                  <p:tgtEl>
+                    <p:sldTgt/>
+                  </p:tgtEl>
+                </p:cond>
+              </p:nextCondLst>
+            </p:seq>
+          </p:childTnLst>
+        </p:cTn>
+      </p:par>
+    </p:tnLst>
+  </p:timing>
 </p:sld>
 </file>
 
@@ -3304,9 +3388,33 @@
           </a:prstGeom>
         </p:spPr>
       </p:pic>
-      <p:sp>
-        <p:nvSpPr>
-          <p:cNvPr id="3" name="TextBox 2"/>
+      <p:pic>
+        <p:nvPicPr>
+          <p:cNvPr id="3" name="Picture 2" descr="_slide_grid.png"/>
+          <p:cNvPicPr>
+            <a:picLocks noChangeAspect="1"/>
+          </p:cNvPicPr>
+          <p:nvPr/>
+        </p:nvPicPr>
+        <p:blipFill>
+          <a:blip r:embed="rId3"/>
+          <a:stretch>
+            <a:fillRect/>
+          </a:stretch>
+        </p:blipFill>
+        <p:spPr>
+          <a:xfrm>
+            <a:off x="-685800" y="-685800"/>
+            <a:ext cx="13563295" cy="8229600"/>
+          </a:xfrm>
+          <a:prstGeom prst="rect">
+            <a:avLst/>
+          </a:prstGeom>
+        </p:spPr>
+      </p:pic>
+      <p:sp>
+        <p:nvSpPr>
+          <p:cNvPr id="6" name="TextBox 5"/>
           <p:cNvSpPr txBox="1"/>
           <p:nvPr/>
         </p:nvSpPr>
@@ -3341,7 +3449,7 @@
       </p:sp>
       <p:sp>
         <p:nvSpPr>
-          <p:cNvPr id="4" name="Rounded Rectangle 3"/>
+          <p:cNvPr id="7" name="Rounded Rectangle 6"/>
           <p:cNvSpPr/>
           <p:nvPr/>
         </p:nvSpPr>
@@ -3388,7 +3496,7 @@
       </p:sp>
       <p:sp>
         <p:nvSpPr>
-          <p:cNvPr id="5" name="TextBox 4"/>
+          <p:cNvPr id="8" name="TextBox 7"/>
           <p:cNvSpPr txBox="1"/>
           <p:nvPr/>
         </p:nvSpPr>
@@ -3423,7 +3531,7 @@
       </p:sp>
       <p:sp>
         <p:nvSpPr>
-          <p:cNvPr id="6" name="TextBox 5"/>
+          <p:cNvPr id="9" name="TextBox 8"/>
           <p:cNvSpPr txBox="1"/>
           <p:nvPr/>
         </p:nvSpPr>
@@ -3458,7 +3566,7 @@
       </p:sp>
       <p:sp>
         <p:nvSpPr>
-          <p:cNvPr id="7" name="TextBox 6"/>
+          <p:cNvPr id="10" name="TextBox 9"/>
           <p:cNvSpPr txBox="1"/>
           <p:nvPr/>
         </p:nvSpPr>
@@ -3493,7 +3601,7 @@
       </p:sp>
       <p:sp>
         <p:nvSpPr>
-          <p:cNvPr id="8" name="Rounded Rectangle 7"/>
+          <p:cNvPr id="11" name="Rounded Rectangle 10"/>
           <p:cNvSpPr/>
           <p:nvPr/>
         </p:nvSpPr>
@@ -3540,7 +3648,7 @@
       </p:sp>
       <p:sp>
         <p:nvSpPr>
-          <p:cNvPr id="9" name="TextBox 8"/>
+          <p:cNvPr id="12" name="TextBox 11"/>
           <p:cNvSpPr txBox="1"/>
           <p:nvPr/>
         </p:nvSpPr>
@@ -3575,7 +3683,7 @@
       </p:sp>
       <p:sp>
         <p:nvSpPr>
-          <p:cNvPr id="10" name="TextBox 9"/>
+          <p:cNvPr id="13" name="TextBox 12"/>
           <p:cNvSpPr txBox="1"/>
           <p:nvPr/>
         </p:nvSpPr>
@@ -3610,7 +3718,7 @@
       </p:sp>
       <p:sp>
         <p:nvSpPr>
-          <p:cNvPr id="11" name="TextBox 10"/>
+          <p:cNvPr id="14" name="TextBox 13"/>
           <p:cNvSpPr txBox="1"/>
           <p:nvPr/>
         </p:nvSpPr>
@@ -3645,7 +3753,7 @@
       </p:sp>
       <p:sp>
         <p:nvSpPr>
-          <p:cNvPr id="12" name="TextBox 11"/>
+          <p:cNvPr id="15" name="TextBox 14"/>
           <p:cNvSpPr txBox="1"/>
           <p:nvPr/>
         </p:nvSpPr>
@@ -3680,7 +3788,7 @@
       </p:sp>
       <p:sp>
         <p:nvSpPr>
-          <p:cNvPr id="13" name="Down Arrow 12"/>
+          <p:cNvPr id="16" name="Down Arrow 15"/>
           <p:cNvSpPr/>
           <p:nvPr/>
         </p:nvSpPr>
@@ -3726,6 +3834,66 @@
   <p:clrMapOvr>
     <a:masterClrMapping/>
   </p:clrMapOvr>
+  <p:timing>
+    <p:tnLst>
+      <p:par>
+        <p:cTn id="1" dur="indefinite" restart="never" nodeType="tmRoot">
+          <p:childTnLst>
+            <p:seq concurrent="1" nextAc="seek">
+              <p:cTn id="2" dur="indefinite" nodeType="mainSeq">
+                <p:childTnLst>
+                  <p:par>
+                    <p:cTn id="3" fill="hold">
+                      <p:stCondLst>
+                        <p:cond delay="0"/>
+                      </p:stCondLst>
+                      <p:childTnLst>
+                        <p:par>
+                          <p:cTn id="4" fill="hold">
+                            <p:stCondLst>
+                              <p:cond delay="0"/>
+                            </p:stCondLst>
+                            <p:childTnLst>
+                              <p:animMotion origin="layout" path="M 0 0 L 0.03 0.03" pathEditMode="relative" ptsTypes="AA" rAng="0">
+                                <p:cBhvr>
+                                  <p:cTn id="5" dur="8000" repeatCount="indefinite" autoRev="1" fill="hold">
+                                    <p:stCondLst>
+                                      <p:cond delay="0"/>
+                                    </p:stCondLst>
+                                  </p:cTn>
+                                  <p:tgtEl>
+                                    <p:spTgt spid="3"/>
+                                  </p:tgtEl>
+                                </p:cBhvr>
+                              </p:animMotion>
+                            </p:childTnLst>
+                          </p:cTn>
+                        </p:par>
+                      </p:childTnLst>
+                    </p:cTn>
+                  </p:par>
+                </p:childTnLst>
+              </p:cTn>
+              <p:prevCondLst>
+                <p:cond evt="onPrev" delay="0">
+                  <p:tgtEl>
+                    <p:sldTgt/>
+                  </p:tgtEl>
+                </p:cond>
+              </p:prevCondLst>
+              <p:nextCondLst>
+                <p:cond evt="onNext" delay="0">
+                  <p:tgtEl>
+                    <p:sldTgt/>
+                  </p:tgtEl>
+                </p:cond>
+              </p:nextCondLst>
+            </p:seq>
+          </p:childTnLst>
+        </p:cTn>
+      </p:par>
+    </p:tnLst>
+  </p:timing>
 </p:sld>
 </file>
 
@@ -3771,9 +3939,33 @@
           </a:prstGeom>
         </p:spPr>
       </p:pic>
-      <p:sp>
-        <p:nvSpPr>
-          <p:cNvPr id="3" name="Rounded Rectangle 2"/>
+      <p:pic>
+        <p:nvPicPr>
+          <p:cNvPr id="3" name="Picture 2" descr="_slide_grid.png"/>
+          <p:cNvPicPr>
+            <a:picLocks noChangeAspect="1"/>
+          </p:cNvPicPr>
+          <p:nvPr/>
+        </p:nvPicPr>
+        <p:blipFill>
+          <a:blip r:embed="rId3"/>
+          <a:stretch>
+            <a:fillRect/>
+          </a:stretch>
+        </p:blipFill>
+        <p:spPr>
+          <a:xfrm>
+            <a:off x="-685800" y="-685800"/>
+            <a:ext cx="13563295" cy="8229600"/>
+          </a:xfrm>
+          <a:prstGeom prst="rect">
+            <a:avLst/>
+          </a:prstGeom>
+        </p:spPr>
+      </p:pic>
+      <p:sp>
+        <p:nvSpPr>
+          <p:cNvPr id="6" name="Rounded Rectangle 5"/>
           <p:cNvSpPr/>
           <p:nvPr/>
         </p:nvSpPr>
@@ -3820,7 +4012,7 @@
       </p:sp>
       <p:sp>
         <p:nvSpPr>
-          <p:cNvPr id="4" name="Oval 3"/>
+          <p:cNvPr id="7" name="Oval 6"/>
           <p:cNvSpPr/>
           <p:nvPr/>
         </p:nvSpPr>
@@ -3863,7 +4055,7 @@
       </p:sp>
       <p:sp>
         <p:nvSpPr>
-          <p:cNvPr id="5" name="Oval 4"/>
+          <p:cNvPr id="8" name="Oval 7"/>
           <p:cNvSpPr/>
           <p:nvPr/>
         </p:nvSpPr>
@@ -3906,7 +4098,7 @@
       </p:sp>
       <p:sp>
         <p:nvSpPr>
-          <p:cNvPr id="6" name="Oval 5"/>
+          <p:cNvPr id="9" name="Oval 8"/>
           <p:cNvSpPr/>
           <p:nvPr/>
         </p:nvSpPr>
@@ -3949,7 +4141,7 @@
       </p:sp>
       <p:sp>
         <p:nvSpPr>
-          <p:cNvPr id="7" name="TextBox 6"/>
+          <p:cNvPr id="10" name="TextBox 9"/>
           <p:cNvSpPr txBox="1"/>
           <p:nvPr/>
         </p:nvSpPr>
@@ -3984,7 +4176,7 @@
       </p:sp>
       <p:sp>
         <p:nvSpPr>
-          <p:cNvPr id="8" name="TextBox 7"/>
+          <p:cNvPr id="11" name="TextBox 10"/>
           <p:cNvSpPr txBox="1"/>
           <p:nvPr/>
         </p:nvSpPr>
@@ -4028,7 +4220,7 @@
       </p:sp>
       <p:sp>
         <p:nvSpPr>
-          <p:cNvPr id="9" name="Right Arrow 8"/>
+          <p:cNvPr id="12" name="Right Arrow 11"/>
           <p:cNvSpPr/>
           <p:nvPr/>
         </p:nvSpPr>
@@ -4071,7 +4263,7 @@
       </p:sp>
       <p:sp>
         <p:nvSpPr>
-          <p:cNvPr id="10" name="Rounded Rectangle 9"/>
+          <p:cNvPr id="13" name="Rounded Rectangle 12"/>
           <p:cNvSpPr/>
           <p:nvPr/>
         </p:nvSpPr>
@@ -4118,7 +4310,7 @@
       </p:sp>
       <p:sp>
         <p:nvSpPr>
-          <p:cNvPr id="11" name="Oval 10"/>
+          <p:cNvPr id="14" name="Oval 13"/>
           <p:cNvSpPr/>
           <p:nvPr/>
         </p:nvSpPr>
@@ -4161,7 +4353,7 @@
       </p:sp>
       <p:sp>
         <p:nvSpPr>
-          <p:cNvPr id="12" name="Oval 11"/>
+          <p:cNvPr id="15" name="Oval 14"/>
           <p:cNvSpPr/>
           <p:nvPr/>
         </p:nvSpPr>
@@ -4204,7 +4396,7 @@
       </p:sp>
       <p:sp>
         <p:nvSpPr>
-          <p:cNvPr id="13" name="Oval 12"/>
+          <p:cNvPr id="16" name="Oval 15"/>
           <p:cNvSpPr/>
           <p:nvPr/>
         </p:nvSpPr>
@@ -4247,7 +4439,7 @@
       </p:sp>
       <p:sp>
         <p:nvSpPr>
-          <p:cNvPr id="14" name="Rounded Rectangle 13"/>
+          <p:cNvPr id="17" name="Rounded Rectangle 16"/>
           <p:cNvSpPr/>
           <p:nvPr/>
         </p:nvSpPr>
@@ -4292,7 +4484,7 @@
       </p:sp>
       <p:sp>
         <p:nvSpPr>
-          <p:cNvPr id="15" name="Rounded Rectangle 14"/>
+          <p:cNvPr id="18" name="Rounded Rectangle 17"/>
           <p:cNvSpPr/>
           <p:nvPr/>
         </p:nvSpPr>
@@ -4337,7 +4529,7 @@
       </p:sp>
       <p:sp>
         <p:nvSpPr>
-          <p:cNvPr id="16" name="Rounded Rectangle 15"/>
+          <p:cNvPr id="19" name="Rounded Rectangle 18"/>
           <p:cNvSpPr/>
           <p:nvPr/>
         </p:nvSpPr>
@@ -4382,7 +4574,7 @@
       </p:sp>
       <p:sp>
         <p:nvSpPr>
-          <p:cNvPr id="17" name="Rounded Rectangle 16"/>
+          <p:cNvPr id="20" name="Rounded Rectangle 19"/>
           <p:cNvSpPr/>
           <p:nvPr/>
         </p:nvSpPr>
@@ -4427,7 +4619,7 @@
       </p:sp>
       <p:sp>
         <p:nvSpPr>
-          <p:cNvPr id="18" name="Rounded Rectangle 17"/>
+          <p:cNvPr id="21" name="Rounded Rectangle 20"/>
           <p:cNvSpPr/>
           <p:nvPr/>
         </p:nvSpPr>
@@ -4472,7 +4664,7 @@
       </p:sp>
       <p:sp>
         <p:nvSpPr>
-          <p:cNvPr id="19" name="Rounded Rectangle 18"/>
+          <p:cNvPr id="22" name="Rounded Rectangle 21"/>
           <p:cNvSpPr/>
           <p:nvPr/>
         </p:nvSpPr>
@@ -4517,7 +4709,7 @@
       </p:sp>
       <p:sp>
         <p:nvSpPr>
-          <p:cNvPr id="20" name="Rounded Rectangle 19"/>
+          <p:cNvPr id="23" name="Rounded Rectangle 22"/>
           <p:cNvSpPr/>
           <p:nvPr/>
         </p:nvSpPr>
@@ -4562,7 +4754,7 @@
       </p:sp>
       <p:sp>
         <p:nvSpPr>
-          <p:cNvPr id="21" name="Rounded Rectangle 20"/>
+          <p:cNvPr id="24" name="Rounded Rectangle 23"/>
           <p:cNvSpPr/>
           <p:nvPr/>
         </p:nvSpPr>
@@ -4610,6 +4802,66 @@
   <p:clrMapOvr>
     <a:masterClrMapping/>
   </p:clrMapOvr>
+  <p:timing>
+    <p:tnLst>
+      <p:par>
+        <p:cTn id="1" dur="indefinite" restart="never" nodeType="tmRoot">
+          <p:childTnLst>
+            <p:seq concurrent="1" nextAc="seek">
+              <p:cTn id="2" dur="indefinite" nodeType="mainSeq">
+                <p:childTnLst>
+                  <p:par>
+                    <p:cTn id="3" fill="hold">
+                      <p:stCondLst>
+                        <p:cond delay="0"/>
+                      </p:stCondLst>
+                      <p:childTnLst>
+                        <p:par>
+                          <p:cTn id="4" fill="hold">
+                            <p:stCondLst>
+                              <p:cond delay="0"/>
+                            </p:stCondLst>
+                            <p:childTnLst>
+                              <p:animMotion origin="layout" path="M 0 0 L 0.03 0.03" pathEditMode="relative" ptsTypes="AA" rAng="0">
+                                <p:cBhvr>
+                                  <p:cTn id="5" dur="8000" repeatCount="indefinite" autoRev="1" fill="hold">
+                                    <p:stCondLst>
+                                      <p:cond delay="0"/>
+                                    </p:stCondLst>
+                                  </p:cTn>
+                                  <p:tgtEl>
+                                    <p:spTgt spid="3"/>
+                                  </p:tgtEl>
+                                </p:cBhvr>
+                              </p:animMotion>
+                            </p:childTnLst>
+                          </p:cTn>
+                        </p:par>
+                      </p:childTnLst>
+                    </p:cTn>
+                  </p:par>
+                </p:childTnLst>
+              </p:cTn>
+              <p:prevCondLst>
+                <p:cond evt="onPrev" delay="0">
+                  <p:tgtEl>
+                    <p:sldTgt/>
+                  </p:tgtEl>
+                </p:cond>
+              </p:prevCondLst>
+              <p:nextCondLst>
+                <p:cond evt="onNext" delay="0">
+                  <p:tgtEl>
+                    <p:sldTgt/>
+                  </p:tgtEl>
+                </p:cond>
+              </p:nextCondLst>
+            </p:seq>
+          </p:childTnLst>
+        </p:cTn>
+      </p:par>
+    </p:tnLst>
+  </p:timing>
 </p:sld>
 </file>
 
@@ -4655,9 +4907,33 @@
           </a:prstGeom>
         </p:spPr>
       </p:pic>
-      <p:sp>
-        <p:nvSpPr>
-          <p:cNvPr id="3" name="TextBox 2"/>
+      <p:pic>
+        <p:nvPicPr>
+          <p:cNvPr id="3" name="Picture 2" descr="_slide_grid.png"/>
+          <p:cNvPicPr>
+            <a:picLocks noChangeAspect="1"/>
+          </p:cNvPicPr>
+          <p:nvPr/>
+        </p:nvPicPr>
+        <p:blipFill>
+          <a:blip r:embed="rId3"/>
+          <a:stretch>
+            <a:fillRect/>
+          </a:stretch>
+        </p:blipFill>
+        <p:spPr>
+          <a:xfrm>
+            <a:off x="-685800" y="-685800"/>
+            <a:ext cx="13563295" cy="8229600"/>
+          </a:xfrm>
+          <a:prstGeom prst="rect">
+            <a:avLst/>
+          </a:prstGeom>
+        </p:spPr>
+      </p:pic>
+      <p:sp>
+        <p:nvSpPr>
+          <p:cNvPr id="6" name="TextBox 5"/>
           <p:cNvSpPr txBox="1"/>
           <p:nvPr/>
         </p:nvSpPr>
@@ -4692,7 +4968,7 @@
       </p:sp>
       <p:sp>
         <p:nvSpPr>
-          <p:cNvPr id="4" name="TextBox 3"/>
+          <p:cNvPr id="7" name="TextBox 6"/>
           <p:cNvSpPr txBox="1"/>
           <p:nvPr/>
         </p:nvSpPr>
@@ -4727,7 +5003,7 @@
       </p:sp>
       <p:sp>
         <p:nvSpPr>
-          <p:cNvPr id="5" name="TextBox 4"/>
+          <p:cNvPr id="8" name="TextBox 7"/>
           <p:cNvSpPr txBox="1"/>
           <p:nvPr/>
         </p:nvSpPr>
@@ -4762,7 +5038,7 @@
       </p:sp>
       <p:sp>
         <p:nvSpPr>
-          <p:cNvPr id="6" name="TextBox 5"/>
+          <p:cNvPr id="9" name="TextBox 8"/>
           <p:cNvSpPr txBox="1"/>
           <p:nvPr/>
         </p:nvSpPr>
@@ -4797,7 +5073,7 @@
       </p:sp>
       <p:sp>
         <p:nvSpPr>
-          <p:cNvPr id="7" name="TextBox 6"/>
+          <p:cNvPr id="10" name="TextBox 9"/>
           <p:cNvSpPr txBox="1"/>
           <p:nvPr/>
         </p:nvSpPr>
@@ -4832,7 +5108,7 @@
       </p:sp>
       <p:sp>
         <p:nvSpPr>
-          <p:cNvPr id="8" name="TextBox 7"/>
+          <p:cNvPr id="11" name="TextBox 10"/>
           <p:cNvSpPr txBox="1"/>
           <p:nvPr/>
         </p:nvSpPr>
@@ -4867,7 +5143,7 @@
       </p:sp>
       <p:sp>
         <p:nvSpPr>
-          <p:cNvPr id="9" name="TextBox 8"/>
+          <p:cNvPr id="12" name="TextBox 11"/>
           <p:cNvSpPr txBox="1"/>
           <p:nvPr/>
         </p:nvSpPr>
@@ -4902,7 +5178,7 @@
       </p:sp>
       <p:sp>
         <p:nvSpPr>
-          <p:cNvPr id="10" name="TextBox 9"/>
+          <p:cNvPr id="13" name="TextBox 12"/>
           <p:cNvSpPr txBox="1"/>
           <p:nvPr/>
         </p:nvSpPr>
@@ -4937,7 +5213,7 @@
       </p:sp>
       <p:sp>
         <p:nvSpPr>
-          <p:cNvPr id="11" name="TextBox 10"/>
+          <p:cNvPr id="14" name="TextBox 13"/>
           <p:cNvSpPr txBox="1"/>
           <p:nvPr/>
         </p:nvSpPr>
@@ -4972,7 +5248,7 @@
       </p:sp>
       <p:sp>
         <p:nvSpPr>
-          <p:cNvPr id="12" name="TextBox 11"/>
+          <p:cNvPr id="15" name="TextBox 14"/>
           <p:cNvSpPr txBox="1"/>
           <p:nvPr/>
         </p:nvSpPr>
@@ -5007,7 +5283,7 @@
       </p:sp>
       <p:sp>
         <p:nvSpPr>
-          <p:cNvPr id="13" name="TextBox 12"/>
+          <p:cNvPr id="16" name="TextBox 15"/>
           <p:cNvSpPr txBox="1"/>
           <p:nvPr/>
         </p:nvSpPr>
@@ -5042,7 +5318,7 @@
       </p:sp>
       <p:sp>
         <p:nvSpPr>
-          <p:cNvPr id="14" name="TextBox 13"/>
+          <p:cNvPr id="17" name="TextBox 16"/>
           <p:cNvSpPr txBox="1"/>
           <p:nvPr/>
         </p:nvSpPr>
@@ -5077,7 +5353,7 @@
       </p:sp>
       <p:sp>
         <p:nvSpPr>
-          <p:cNvPr id="15" name="Rounded Rectangle 14"/>
+          <p:cNvPr id="18" name="Rounded Rectangle 17"/>
           <p:cNvSpPr/>
           <p:nvPr/>
         </p:nvSpPr>
@@ -5124,7 +5400,7 @@
       </p:sp>
       <p:sp>
         <p:nvSpPr>
-          <p:cNvPr id="16" name="Rounded Rectangle 15"/>
+          <p:cNvPr id="19" name="Rounded Rectangle 18"/>
           <p:cNvSpPr/>
           <p:nvPr/>
         </p:nvSpPr>
@@ -5171,7 +5447,7 @@
       </p:sp>
       <p:sp>
         <p:nvSpPr>
-          <p:cNvPr id="17" name="Rounded Rectangle 16"/>
+          <p:cNvPr id="20" name="Rounded Rectangle 19"/>
           <p:cNvSpPr/>
           <p:nvPr/>
         </p:nvSpPr>
@@ -5218,7 +5494,7 @@
       </p:sp>
       <p:sp>
         <p:nvSpPr>
-          <p:cNvPr id="18" name="Rounded Rectangle 17"/>
+          <p:cNvPr id="21" name="Rounded Rectangle 20"/>
           <p:cNvSpPr/>
           <p:nvPr/>
         </p:nvSpPr>
@@ -5265,7 +5541,7 @@
       </p:sp>
       <p:sp>
         <p:nvSpPr>
-          <p:cNvPr id="19" name="TextBox 18"/>
+          <p:cNvPr id="22" name="TextBox 21"/>
           <p:cNvSpPr txBox="1"/>
           <p:nvPr/>
         </p:nvSpPr>
@@ -5300,7 +5576,7 @@
       </p:sp>
       <p:sp>
         <p:nvSpPr>
-          <p:cNvPr id="20" name="Rounded Rectangle 19"/>
+          <p:cNvPr id="23" name="Rounded Rectangle 22"/>
           <p:cNvSpPr/>
           <p:nvPr/>
         </p:nvSpPr>
@@ -5347,7 +5623,7 @@
       </p:sp>
       <p:sp>
         <p:nvSpPr>
-          <p:cNvPr id="21" name="TextBox 20"/>
+          <p:cNvPr id="24" name="TextBox 23"/>
           <p:cNvSpPr txBox="1"/>
           <p:nvPr/>
         </p:nvSpPr>
@@ -5382,7 +5658,7 @@
       </p:sp>
       <p:sp>
         <p:nvSpPr>
-          <p:cNvPr id="22" name="Rounded Rectangle 21"/>
+          <p:cNvPr id="25" name="Rounded Rectangle 24"/>
           <p:cNvSpPr/>
           <p:nvPr/>
         </p:nvSpPr>
@@ -5429,7 +5705,7 @@
       </p:sp>
       <p:sp>
         <p:nvSpPr>
-          <p:cNvPr id="23" name="Rounded Rectangle 22"/>
+          <p:cNvPr id="26" name="Rounded Rectangle 25"/>
           <p:cNvSpPr/>
           <p:nvPr/>
         </p:nvSpPr>
@@ -5476,7 +5752,7 @@
       </p:sp>
       <p:sp>
         <p:nvSpPr>
-          <p:cNvPr id="24" name="Rounded Rectangle 23"/>
+          <p:cNvPr id="27" name="Rounded Rectangle 26"/>
           <p:cNvSpPr/>
           <p:nvPr/>
         </p:nvSpPr>
@@ -5523,7 +5799,7 @@
       </p:sp>
       <p:sp>
         <p:nvSpPr>
-          <p:cNvPr id="25" name="TextBox 24"/>
+          <p:cNvPr id="28" name="TextBox 27"/>
           <p:cNvSpPr txBox="1"/>
           <p:nvPr/>
         </p:nvSpPr>
@@ -5558,7 +5834,7 @@
       </p:sp>
       <p:sp>
         <p:nvSpPr>
-          <p:cNvPr id="26" name="Rounded Rectangle 25"/>
+          <p:cNvPr id="29" name="Rounded Rectangle 28"/>
           <p:cNvSpPr/>
           <p:nvPr/>
         </p:nvSpPr>
@@ -5605,7 +5881,7 @@
       </p:sp>
       <p:sp>
         <p:nvSpPr>
-          <p:cNvPr id="27" name="Rounded Rectangle 26"/>
+          <p:cNvPr id="30" name="Rounded Rectangle 29"/>
           <p:cNvSpPr/>
           <p:nvPr/>
         </p:nvSpPr>
@@ -5652,7 +5928,7 @@
       </p:sp>
       <p:sp>
         <p:nvSpPr>
-          <p:cNvPr id="28" name="Rounded Rectangle 27"/>
+          <p:cNvPr id="31" name="Rounded Rectangle 30"/>
           <p:cNvSpPr/>
           <p:nvPr/>
         </p:nvSpPr>
@@ -5699,7 +5975,7 @@
       </p:sp>
       <p:sp>
         <p:nvSpPr>
-          <p:cNvPr id="29" name="Rounded Rectangle 28"/>
+          <p:cNvPr id="32" name="Rounded Rectangle 31"/>
           <p:cNvSpPr/>
           <p:nvPr/>
         </p:nvSpPr>
@@ -5746,7 +6022,7 @@
       </p:sp>
       <p:sp>
         <p:nvSpPr>
-          <p:cNvPr id="30" name="TextBox 29"/>
+          <p:cNvPr id="33" name="TextBox 32"/>
           <p:cNvSpPr txBox="1"/>
           <p:nvPr/>
         </p:nvSpPr>
@@ -5781,7 +6057,7 @@
       </p:sp>
       <p:sp>
         <p:nvSpPr>
-          <p:cNvPr id="31" name="Rounded Rectangle 30"/>
+          <p:cNvPr id="34" name="Rounded Rectangle 33"/>
           <p:cNvSpPr/>
           <p:nvPr/>
         </p:nvSpPr>
@@ -5828,7 +6104,7 @@
       </p:sp>
       <p:sp>
         <p:nvSpPr>
-          <p:cNvPr id="32" name="Rounded Rectangle 31"/>
+          <p:cNvPr id="35" name="Rounded Rectangle 34"/>
           <p:cNvSpPr/>
           <p:nvPr/>
         </p:nvSpPr>
@@ -5875,7 +6151,7 @@
       </p:sp>
       <p:sp>
         <p:nvSpPr>
-          <p:cNvPr id="33" name="TextBox 32"/>
+          <p:cNvPr id="36" name="TextBox 35"/>
           <p:cNvSpPr txBox="1"/>
           <p:nvPr/>
         </p:nvSpPr>
@@ -5910,7 +6186,7 @@
       </p:sp>
       <p:sp>
         <p:nvSpPr>
-          <p:cNvPr id="34" name="Rounded Rectangle 33"/>
+          <p:cNvPr id="37" name="Rounded Rectangle 36"/>
           <p:cNvSpPr/>
           <p:nvPr/>
         </p:nvSpPr>
@@ -5957,7 +6233,7 @@
       </p:sp>
       <p:sp>
         <p:nvSpPr>
-          <p:cNvPr id="35" name="Rounded Rectangle 34"/>
+          <p:cNvPr id="38" name="Rounded Rectangle 37"/>
           <p:cNvSpPr/>
           <p:nvPr/>
         </p:nvSpPr>
@@ -6004,7 +6280,7 @@
       </p:sp>
       <p:sp>
         <p:nvSpPr>
-          <p:cNvPr id="36" name="Rounded Rectangle 35"/>
+          <p:cNvPr id="39" name="Rounded Rectangle 38"/>
           <p:cNvSpPr/>
           <p:nvPr/>
         </p:nvSpPr>
@@ -6051,7 +6327,7 @@
       </p:sp>
       <p:sp>
         <p:nvSpPr>
-          <p:cNvPr id="37" name="Rectangle 36"/>
+          <p:cNvPr id="40" name="Rectangle 39"/>
           <p:cNvSpPr/>
           <p:nvPr/>
         </p:nvSpPr>
@@ -6097,6 +6373,66 @@
   <p:clrMapOvr>
     <a:masterClrMapping/>
   </p:clrMapOvr>
+  <p:timing>
+    <p:tnLst>
+      <p:par>
+        <p:cTn id="1" dur="indefinite" restart="never" nodeType="tmRoot">
+          <p:childTnLst>
+            <p:seq concurrent="1" nextAc="seek">
+              <p:cTn id="2" dur="indefinite" nodeType="mainSeq">
+                <p:childTnLst>
+                  <p:par>
+                    <p:cTn id="3" fill="hold">
+                      <p:stCondLst>
+                        <p:cond delay="0"/>
+                      </p:stCondLst>
+                      <p:childTnLst>
+                        <p:par>
+                          <p:cTn id="4" fill="hold">
+                            <p:stCondLst>
+                              <p:cond delay="0"/>
+                            </p:stCondLst>
+                            <p:childTnLst>
+                              <p:animMotion origin="layout" path="M 0 0 L 0.03 0.03" pathEditMode="relative" ptsTypes="AA" rAng="0">
+                                <p:cBhvr>
+                                  <p:cTn id="5" dur="8000" repeatCount="indefinite" autoRev="1" fill="hold">
+                                    <p:stCondLst>
+                                      <p:cond delay="0"/>
+                                    </p:stCondLst>
+                                  </p:cTn>
+                                  <p:tgtEl>
+                                    <p:spTgt spid="3"/>
+                                  </p:tgtEl>
+                                </p:cBhvr>
+                              </p:animMotion>
+                            </p:childTnLst>
+                          </p:cTn>
+                        </p:par>
+                      </p:childTnLst>
+                    </p:cTn>
+                  </p:par>
+                </p:childTnLst>
+              </p:cTn>
+              <p:prevCondLst>
+                <p:cond evt="onPrev" delay="0">
+                  <p:tgtEl>
+                    <p:sldTgt/>
+                  </p:tgtEl>
+                </p:cond>
+              </p:prevCondLst>
+              <p:nextCondLst>
+                <p:cond evt="onNext" delay="0">
+                  <p:tgtEl>
+                    <p:sldTgt/>
+                  </p:tgtEl>
+                </p:cond>
+              </p:nextCondLst>
+            </p:seq>
+          </p:childTnLst>
+        </p:cTn>
+      </p:par>
+    </p:tnLst>
+  </p:timing>
 </p:sld>
 </file>
 
@@ -6142,9 +6478,33 @@
           </a:prstGeom>
         </p:spPr>
       </p:pic>
-      <p:sp>
-        <p:nvSpPr>
-          <p:cNvPr id="3" name="TextBox 2"/>
+      <p:pic>
+        <p:nvPicPr>
+          <p:cNvPr id="3" name="Picture 2" descr="_slide_grid.png"/>
+          <p:cNvPicPr>
+            <a:picLocks noChangeAspect="1"/>
+          </p:cNvPicPr>
+          <p:nvPr/>
+        </p:nvPicPr>
+        <p:blipFill>
+          <a:blip r:embed="rId3"/>
+          <a:stretch>
+            <a:fillRect/>
+          </a:stretch>
+        </p:blipFill>
+        <p:spPr>
+          <a:xfrm>
+            <a:off x="-685800" y="-685800"/>
+            <a:ext cx="13563295" cy="8229600"/>
+          </a:xfrm>
+          <a:prstGeom prst="rect">
+            <a:avLst/>
+          </a:prstGeom>
+        </p:spPr>
+      </p:pic>
+      <p:sp>
+        <p:nvSpPr>
+          <p:cNvPr id="6" name="TextBox 5"/>
           <p:cNvSpPr txBox="1"/>
           <p:nvPr/>
         </p:nvSpPr>
@@ -6179,7 +6539,7 @@
       </p:sp>
       <p:sp>
         <p:nvSpPr>
-          <p:cNvPr id="4" name="TextBox 3"/>
+          <p:cNvPr id="7" name="TextBox 6"/>
           <p:cNvSpPr txBox="1"/>
           <p:nvPr/>
         </p:nvSpPr>
@@ -6214,7 +6574,7 @@
       </p:sp>
       <p:sp>
         <p:nvSpPr>
-          <p:cNvPr id="5" name="TextBox 4"/>
+          <p:cNvPr id="8" name="TextBox 7"/>
           <p:cNvSpPr txBox="1"/>
           <p:nvPr/>
         </p:nvSpPr>
@@ -6249,7 +6609,7 @@
       </p:sp>
       <p:sp>
         <p:nvSpPr>
-          <p:cNvPr id="6" name="TextBox 5"/>
+          <p:cNvPr id="9" name="TextBox 8"/>
           <p:cNvSpPr txBox="1"/>
           <p:nvPr/>
         </p:nvSpPr>
@@ -6284,7 +6644,7 @@
       </p:sp>
       <p:sp>
         <p:nvSpPr>
-          <p:cNvPr id="7" name="Rounded Rectangle 6"/>
+          <p:cNvPr id="10" name="Rounded Rectangle 9"/>
           <p:cNvSpPr/>
           <p:nvPr/>
         </p:nvSpPr>
@@ -6331,7 +6691,7 @@
       </p:sp>
       <p:sp>
         <p:nvSpPr>
-          <p:cNvPr id="8" name="Oval 7"/>
+          <p:cNvPr id="11" name="Oval 10"/>
           <p:cNvSpPr/>
           <p:nvPr/>
         </p:nvSpPr>
@@ -6374,7 +6734,7 @@
       </p:sp>
       <p:sp>
         <p:nvSpPr>
-          <p:cNvPr id="9" name="Oval 8"/>
+          <p:cNvPr id="12" name="Oval 11"/>
           <p:cNvSpPr/>
           <p:nvPr/>
         </p:nvSpPr>
@@ -6417,7 +6777,7 @@
       </p:sp>
       <p:sp>
         <p:nvSpPr>
-          <p:cNvPr id="10" name="Oval 9"/>
+          <p:cNvPr id="13" name="Oval 12"/>
           <p:cNvSpPr/>
           <p:nvPr/>
         </p:nvSpPr>
@@ -6460,7 +6820,7 @@
       </p:sp>
       <p:sp>
         <p:nvSpPr>
-          <p:cNvPr id="11" name="TextBox 10"/>
+          <p:cNvPr id="14" name="TextBox 13"/>
           <p:cNvSpPr txBox="1"/>
           <p:nvPr/>
         </p:nvSpPr>
@@ -6495,7 +6855,7 @@
       </p:sp>
       <p:sp>
         <p:nvSpPr>
-          <p:cNvPr id="12" name="TextBox 11"/>
+          <p:cNvPr id="15" name="TextBox 14"/>
           <p:cNvSpPr txBox="1"/>
           <p:nvPr/>
         </p:nvSpPr>
@@ -6544,7 +6904,7 @@
       </p:sp>
       <p:sp>
         <p:nvSpPr>
-          <p:cNvPr id="13" name="Rounded Rectangle 12"/>
+          <p:cNvPr id="16" name="Rounded Rectangle 15"/>
           <p:cNvSpPr/>
           <p:nvPr/>
         </p:nvSpPr>
@@ -6591,7 +6951,7 @@
       </p:sp>
       <p:sp>
         <p:nvSpPr>
-          <p:cNvPr id="14" name="Oval 13"/>
+          <p:cNvPr id="17" name="Oval 16"/>
           <p:cNvSpPr/>
           <p:nvPr/>
         </p:nvSpPr>
@@ -6634,7 +6994,7 @@
       </p:sp>
       <p:sp>
         <p:nvSpPr>
-          <p:cNvPr id="15" name="Oval 14"/>
+          <p:cNvPr id="18" name="Oval 17"/>
           <p:cNvSpPr/>
           <p:nvPr/>
         </p:nvSpPr>
@@ -6677,7 +7037,7 @@
       </p:sp>
       <p:sp>
         <p:nvSpPr>
-          <p:cNvPr id="16" name="Oval 15"/>
+          <p:cNvPr id="19" name="Oval 18"/>
           <p:cNvSpPr/>
           <p:nvPr/>
         </p:nvSpPr>
@@ -6720,7 +7080,7 @@
       </p:sp>
       <p:sp>
         <p:nvSpPr>
-          <p:cNvPr id="17" name="TextBox 16"/>
+          <p:cNvPr id="20" name="TextBox 19"/>
           <p:cNvSpPr txBox="1"/>
           <p:nvPr/>
         </p:nvSpPr>
@@ -6755,7 +7115,7 @@
       </p:sp>
       <p:sp>
         <p:nvSpPr>
-          <p:cNvPr id="18" name="Rectangle 17"/>
+          <p:cNvPr id="21" name="Rectangle 20"/>
           <p:cNvSpPr/>
           <p:nvPr/>
         </p:nvSpPr>
@@ -6798,7 +7158,7 @@
       </p:sp>
       <p:sp>
         <p:nvSpPr>
-          <p:cNvPr id="19" name="TextBox 18"/>
+          <p:cNvPr id="22" name="TextBox 21"/>
           <p:cNvSpPr txBox="1"/>
           <p:nvPr/>
         </p:nvSpPr>
@@ -6833,7 +7193,7 @@
       </p:sp>
       <p:sp>
         <p:nvSpPr>
-          <p:cNvPr id="20" name="Oval 19"/>
+          <p:cNvPr id="23" name="Oval 22"/>
           <p:cNvSpPr/>
           <p:nvPr/>
         </p:nvSpPr>
@@ -6879,6 +7239,66 @@
   <p:clrMapOvr>
     <a:masterClrMapping/>
   </p:clrMapOvr>
+  <p:timing>
+    <p:tnLst>
+      <p:par>
+        <p:cTn id="1" dur="indefinite" restart="never" nodeType="tmRoot">
+          <p:childTnLst>
+            <p:seq concurrent="1" nextAc="seek">
+              <p:cTn id="2" dur="indefinite" nodeType="mainSeq">
+                <p:childTnLst>
+                  <p:par>
+                    <p:cTn id="3" fill="hold">
+                      <p:stCondLst>
+                        <p:cond delay="0"/>
+                      </p:stCondLst>
+                      <p:childTnLst>
+                        <p:par>
+                          <p:cTn id="4" fill="hold">
+                            <p:stCondLst>
+                              <p:cond delay="0"/>
+                            </p:stCondLst>
+                            <p:childTnLst>
+                              <p:animMotion origin="layout" path="M 0 0 L 0.03 0.03" pathEditMode="relative" ptsTypes="AA" rAng="0">
+                                <p:cBhvr>
+                                  <p:cTn id="5" dur="8000" repeatCount="indefinite" autoRev="1" fill="hold">
+                                    <p:stCondLst>
+                                      <p:cond delay="0"/>
+                                    </p:stCondLst>
+                                  </p:cTn>
+                                  <p:tgtEl>
+                                    <p:spTgt spid="3"/>
+                                  </p:tgtEl>
+                                </p:cBhvr>
+                              </p:animMotion>
+                            </p:childTnLst>
+                          </p:cTn>
+                        </p:par>
+                      </p:childTnLst>
+                    </p:cTn>
+                  </p:par>
+                </p:childTnLst>
+              </p:cTn>
+              <p:prevCondLst>
+                <p:cond evt="onPrev" delay="0">
+                  <p:tgtEl>
+                    <p:sldTgt/>
+                  </p:tgtEl>
+                </p:cond>
+              </p:prevCondLst>
+              <p:nextCondLst>
+                <p:cond evt="onNext" delay="0">
+                  <p:tgtEl>
+                    <p:sldTgt/>
+                  </p:tgtEl>
+                </p:cond>
+              </p:nextCondLst>
+            </p:seq>
+          </p:childTnLst>
+        </p:cTn>
+      </p:par>
+    </p:tnLst>
+  </p:timing>
 </p:sld>
 </file>
 
@@ -6924,9 +7344,33 @@
           </a:prstGeom>
         </p:spPr>
       </p:pic>
-      <p:sp>
-        <p:nvSpPr>
-          <p:cNvPr id="3" name="TextBox 2"/>
+      <p:pic>
+        <p:nvPicPr>
+          <p:cNvPr id="3" name="Picture 2" descr="_slide_grid.png"/>
+          <p:cNvPicPr>
+            <a:picLocks noChangeAspect="1"/>
+          </p:cNvPicPr>
+          <p:nvPr/>
+        </p:nvPicPr>
+        <p:blipFill>
+          <a:blip r:embed="rId3"/>
+          <a:stretch>
+            <a:fillRect/>
+          </a:stretch>
+        </p:blipFill>
+        <p:spPr>
+          <a:xfrm>
+            <a:off x="-685800" y="-685800"/>
+            <a:ext cx="13563295" cy="8229600"/>
+          </a:xfrm>
+          <a:prstGeom prst="rect">
+            <a:avLst/>
+          </a:prstGeom>
+        </p:spPr>
+      </p:pic>
+      <p:sp>
+        <p:nvSpPr>
+          <p:cNvPr id="6" name="TextBox 5"/>
           <p:cNvSpPr txBox="1"/>
           <p:nvPr/>
         </p:nvSpPr>
@@ -6961,7 +7405,7 @@
       </p:sp>
       <p:sp>
         <p:nvSpPr>
-          <p:cNvPr id="4" name="TextBox 3"/>
+          <p:cNvPr id="7" name="TextBox 6"/>
           <p:cNvSpPr txBox="1"/>
           <p:nvPr/>
         </p:nvSpPr>
@@ -6996,7 +7440,7 @@
       </p:sp>
       <p:sp>
         <p:nvSpPr>
-          <p:cNvPr id="5" name="Rounded Rectangle 4"/>
+          <p:cNvPr id="8" name="Rounded Rectangle 7"/>
           <p:cNvSpPr/>
           <p:nvPr/>
         </p:nvSpPr>
@@ -7043,7 +7487,7 @@
       </p:sp>
       <p:sp>
         <p:nvSpPr>
-          <p:cNvPr id="6" name="TextBox 5"/>
+          <p:cNvPr id="9" name="TextBox 8"/>
           <p:cNvSpPr txBox="1"/>
           <p:nvPr/>
         </p:nvSpPr>
@@ -7078,7 +7522,7 @@
       </p:sp>
       <p:sp>
         <p:nvSpPr>
-          <p:cNvPr id="7" name="TextBox 6"/>
+          <p:cNvPr id="10" name="TextBox 9"/>
           <p:cNvSpPr txBox="1"/>
           <p:nvPr/>
         </p:nvSpPr>
@@ -7133,7 +7577,7 @@
       </p:sp>
       <p:sp>
         <p:nvSpPr>
-          <p:cNvPr id="8" name="Rounded Rectangle 7"/>
+          <p:cNvPr id="11" name="Rounded Rectangle 10"/>
           <p:cNvSpPr/>
           <p:nvPr/>
         </p:nvSpPr>
@@ -7180,7 +7624,7 @@
       </p:sp>
       <p:sp>
         <p:nvSpPr>
-          <p:cNvPr id="9" name="TextBox 8"/>
+          <p:cNvPr id="12" name="TextBox 11"/>
           <p:cNvSpPr txBox="1"/>
           <p:nvPr/>
         </p:nvSpPr>
@@ -7215,7 +7659,7 @@
       </p:sp>
       <p:sp>
         <p:nvSpPr>
-          <p:cNvPr id="10" name="TextBox 9"/>
+          <p:cNvPr id="13" name="TextBox 12"/>
           <p:cNvSpPr txBox="1"/>
           <p:nvPr/>
         </p:nvSpPr>
@@ -7270,7 +7714,7 @@
       </p:sp>
       <p:sp>
         <p:nvSpPr>
-          <p:cNvPr id="11" name="Rounded Rectangle 10"/>
+          <p:cNvPr id="14" name="Rounded Rectangle 13"/>
           <p:cNvSpPr/>
           <p:nvPr/>
         </p:nvSpPr>
@@ -7317,7 +7761,7 @@
       </p:sp>
       <p:sp>
         <p:nvSpPr>
-          <p:cNvPr id="12" name="TextBox 11"/>
+          <p:cNvPr id="15" name="TextBox 14"/>
           <p:cNvSpPr txBox="1"/>
           <p:nvPr/>
         </p:nvSpPr>
@@ -7352,7 +7796,7 @@
       </p:sp>
       <p:sp>
         <p:nvSpPr>
-          <p:cNvPr id="13" name="TextBox 12"/>
+          <p:cNvPr id="16" name="TextBox 15"/>
           <p:cNvSpPr txBox="1"/>
           <p:nvPr/>
         </p:nvSpPr>
@@ -7407,7 +7851,7 @@
       </p:sp>
       <p:sp>
         <p:nvSpPr>
-          <p:cNvPr id="14" name="Rounded Rectangle 13"/>
+          <p:cNvPr id="17" name="Rounded Rectangle 16"/>
           <p:cNvSpPr/>
           <p:nvPr/>
         </p:nvSpPr>
@@ -7454,7 +7898,7 @@
       </p:sp>
       <p:sp>
         <p:nvSpPr>
-          <p:cNvPr id="15" name="TextBox 14"/>
+          <p:cNvPr id="18" name="TextBox 17"/>
           <p:cNvSpPr txBox="1"/>
           <p:nvPr/>
         </p:nvSpPr>
@@ -7489,7 +7933,7 @@
       </p:sp>
       <p:sp>
         <p:nvSpPr>
-          <p:cNvPr id="16" name="TextBox 15"/>
+          <p:cNvPr id="19" name="TextBox 18"/>
           <p:cNvSpPr txBox="1"/>
           <p:nvPr/>
         </p:nvSpPr>
@@ -7544,7 +7988,7 @@
       </p:sp>
       <p:sp>
         <p:nvSpPr>
-          <p:cNvPr id="17" name="Rounded Rectangle 16"/>
+          <p:cNvPr id="20" name="Rounded Rectangle 19"/>
           <p:cNvSpPr/>
           <p:nvPr/>
         </p:nvSpPr>
@@ -7591,7 +8035,7 @@
       </p:sp>
       <p:sp>
         <p:nvSpPr>
-          <p:cNvPr id="18" name="TextBox 17"/>
+          <p:cNvPr id="21" name="TextBox 20"/>
           <p:cNvSpPr txBox="1"/>
           <p:nvPr/>
         </p:nvSpPr>
@@ -7626,7 +8070,7 @@
       </p:sp>
       <p:sp>
         <p:nvSpPr>
-          <p:cNvPr id="19" name="TextBox 18"/>
+          <p:cNvPr id="22" name="TextBox 21"/>
           <p:cNvSpPr txBox="1"/>
           <p:nvPr/>
         </p:nvSpPr>
@@ -7681,7 +8125,7 @@
       </p:sp>
       <p:sp>
         <p:nvSpPr>
-          <p:cNvPr id="20" name="TextBox 19"/>
+          <p:cNvPr id="23" name="TextBox 22"/>
           <p:cNvSpPr txBox="1"/>
           <p:nvPr/>
         </p:nvSpPr>
@@ -7719,6 +8163,66 @@
   <p:clrMapOvr>
     <a:masterClrMapping/>
   </p:clrMapOvr>
+  <p:timing>
+    <p:tnLst>
+      <p:par>
+        <p:cTn id="1" dur="indefinite" restart="never" nodeType="tmRoot">
+          <p:childTnLst>
+            <p:seq concurrent="1" nextAc="seek">
+              <p:cTn id="2" dur="indefinite" nodeType="mainSeq">
+                <p:childTnLst>
+                  <p:par>
+                    <p:cTn id="3" fill="hold">
+                      <p:stCondLst>
+                        <p:cond delay="0"/>
+                      </p:stCondLst>
+                      <p:childTnLst>
+                        <p:par>
+                          <p:cTn id="4" fill="hold">
+                            <p:stCondLst>
+                              <p:cond delay="0"/>
+                            </p:stCondLst>
+                            <p:childTnLst>
+                              <p:animMotion origin="layout" path="M 0 0 L 0.03 0.03" pathEditMode="relative" ptsTypes="AA" rAng="0">
+                                <p:cBhvr>
+                                  <p:cTn id="5" dur="8000" repeatCount="indefinite" autoRev="1" fill="hold">
+                                    <p:stCondLst>
+                                      <p:cond delay="0"/>
+                                    </p:stCondLst>
+                                  </p:cTn>
+                                  <p:tgtEl>
+                                    <p:spTgt spid="3"/>
+                                  </p:tgtEl>
+                                </p:cBhvr>
+                              </p:animMotion>
+                            </p:childTnLst>
+                          </p:cTn>
+                        </p:par>
+                      </p:childTnLst>
+                    </p:cTn>
+                  </p:par>
+                </p:childTnLst>
+              </p:cTn>
+              <p:prevCondLst>
+                <p:cond evt="onPrev" delay="0">
+                  <p:tgtEl>
+                    <p:sldTgt/>
+                  </p:tgtEl>
+                </p:cond>
+              </p:prevCondLst>
+              <p:nextCondLst>
+                <p:cond evt="onNext" delay="0">
+                  <p:tgtEl>
+                    <p:sldTgt/>
+                  </p:tgtEl>
+                </p:cond>
+              </p:nextCondLst>
+            </p:seq>
+          </p:childTnLst>
+        </p:cTn>
+      </p:par>
+    </p:tnLst>
+  </p:timing>
 </p:sld>
 </file>
 
@@ -7764,9 +8268,33 @@
           </a:prstGeom>
         </p:spPr>
       </p:pic>
-      <p:sp>
-        <p:nvSpPr>
-          <p:cNvPr id="3" name="TextBox 2"/>
+      <p:pic>
+        <p:nvPicPr>
+          <p:cNvPr id="3" name="Picture 2" descr="_slide_grid.png"/>
+          <p:cNvPicPr>
+            <a:picLocks noChangeAspect="1"/>
+          </p:cNvPicPr>
+          <p:nvPr/>
+        </p:nvPicPr>
+        <p:blipFill>
+          <a:blip r:embed="rId3"/>
+          <a:stretch>
+            <a:fillRect/>
+          </a:stretch>
+        </p:blipFill>
+        <p:spPr>
+          <a:xfrm>
+            <a:off x="-685800" y="-685800"/>
+            <a:ext cx="13563295" cy="8229600"/>
+          </a:xfrm>
+          <a:prstGeom prst="rect">
+            <a:avLst/>
+          </a:prstGeom>
+        </p:spPr>
+      </p:pic>
+      <p:sp>
+        <p:nvSpPr>
+          <p:cNvPr id="6" name="TextBox 5"/>
           <p:cNvSpPr txBox="1"/>
           <p:nvPr/>
         </p:nvSpPr>
@@ -7801,7 +8329,7 @@
       </p:sp>
       <p:sp>
         <p:nvSpPr>
-          <p:cNvPr id="4" name="TextBox 3"/>
+          <p:cNvPr id="7" name="TextBox 6"/>
           <p:cNvSpPr txBox="1"/>
           <p:nvPr/>
         </p:nvSpPr>
@@ -7836,7 +8364,7 @@
       </p:sp>
       <p:sp>
         <p:nvSpPr>
-          <p:cNvPr id="5" name="Rounded Rectangle 4"/>
+          <p:cNvPr id="8" name="Rounded Rectangle 7"/>
           <p:cNvSpPr/>
           <p:nvPr/>
         </p:nvSpPr>
@@ -7883,7 +8411,7 @@
       </p:sp>
       <p:sp>
         <p:nvSpPr>
-          <p:cNvPr id="6" name="TextBox 5"/>
+          <p:cNvPr id="9" name="TextBox 8"/>
           <p:cNvSpPr txBox="1"/>
           <p:nvPr/>
         </p:nvSpPr>
@@ -7918,7 +8446,7 @@
       </p:sp>
       <p:sp>
         <p:nvSpPr>
-          <p:cNvPr id="7" name="TextBox 6"/>
+          <p:cNvPr id="10" name="TextBox 9"/>
           <p:cNvSpPr txBox="1"/>
           <p:nvPr/>
         </p:nvSpPr>
@@ -7953,7 +8481,7 @@
       </p:sp>
       <p:sp>
         <p:nvSpPr>
-          <p:cNvPr id="8" name="Right Arrow 7"/>
+          <p:cNvPr id="11" name="Right Arrow 10"/>
           <p:cNvSpPr/>
           <p:nvPr/>
         </p:nvSpPr>
@@ -7996,7 +8524,7 @@
       </p:sp>
       <p:sp>
         <p:nvSpPr>
-          <p:cNvPr id="9" name="Rounded Rectangle 8"/>
+          <p:cNvPr id="12" name="Rounded Rectangle 11"/>
           <p:cNvSpPr/>
           <p:nvPr/>
         </p:nvSpPr>
@@ -8043,7 +8571,7 @@
       </p:sp>
       <p:sp>
         <p:nvSpPr>
-          <p:cNvPr id="10" name="TextBox 9"/>
+          <p:cNvPr id="13" name="TextBox 12"/>
           <p:cNvSpPr txBox="1"/>
           <p:nvPr/>
         </p:nvSpPr>
@@ -8078,7 +8606,7 @@
       </p:sp>
       <p:sp>
         <p:nvSpPr>
-          <p:cNvPr id="11" name="TextBox 10"/>
+          <p:cNvPr id="14" name="TextBox 13"/>
           <p:cNvSpPr txBox="1"/>
           <p:nvPr/>
         </p:nvSpPr>
@@ -8113,7 +8641,7 @@
       </p:sp>
       <p:sp>
         <p:nvSpPr>
-          <p:cNvPr id="12" name="Right Arrow 11"/>
+          <p:cNvPr id="15" name="Right Arrow 14"/>
           <p:cNvSpPr/>
           <p:nvPr/>
         </p:nvSpPr>
@@ -8156,7 +8684,7 @@
       </p:sp>
       <p:sp>
         <p:nvSpPr>
-          <p:cNvPr id="13" name="Rounded Rectangle 12"/>
+          <p:cNvPr id="16" name="Rounded Rectangle 15"/>
           <p:cNvSpPr/>
           <p:nvPr/>
         </p:nvSpPr>
@@ -8203,7 +8731,7 @@
       </p:sp>
       <p:sp>
         <p:nvSpPr>
-          <p:cNvPr id="14" name="TextBox 13"/>
+          <p:cNvPr id="17" name="TextBox 16"/>
           <p:cNvSpPr txBox="1"/>
           <p:nvPr/>
         </p:nvSpPr>
@@ -8238,7 +8766,7 @@
       </p:sp>
       <p:sp>
         <p:nvSpPr>
-          <p:cNvPr id="15" name="TextBox 14"/>
+          <p:cNvPr id="18" name="TextBox 17"/>
           <p:cNvSpPr txBox="1"/>
           <p:nvPr/>
         </p:nvSpPr>
@@ -8273,7 +8801,7 @@
       </p:sp>
       <p:sp>
         <p:nvSpPr>
-          <p:cNvPr id="16" name="Right Arrow 15"/>
+          <p:cNvPr id="19" name="Right Arrow 18"/>
           <p:cNvSpPr/>
           <p:nvPr/>
         </p:nvSpPr>
@@ -8316,7 +8844,7 @@
       </p:sp>
       <p:sp>
         <p:nvSpPr>
-          <p:cNvPr id="17" name="Rounded Rectangle 16"/>
+          <p:cNvPr id="20" name="Rounded Rectangle 19"/>
           <p:cNvSpPr/>
           <p:nvPr/>
         </p:nvSpPr>
@@ -8363,7 +8891,7 @@
       </p:sp>
       <p:sp>
         <p:nvSpPr>
-          <p:cNvPr id="18" name="TextBox 17"/>
+          <p:cNvPr id="21" name="TextBox 20"/>
           <p:cNvSpPr txBox="1"/>
           <p:nvPr/>
         </p:nvSpPr>
@@ -8398,7 +8926,7 @@
       </p:sp>
       <p:sp>
         <p:nvSpPr>
-          <p:cNvPr id="19" name="TextBox 18"/>
+          <p:cNvPr id="22" name="TextBox 21"/>
           <p:cNvSpPr txBox="1"/>
           <p:nvPr/>
         </p:nvSpPr>
@@ -8433,7 +8961,7 @@
       </p:sp>
       <p:sp>
         <p:nvSpPr>
-          <p:cNvPr id="20" name="TextBox 19"/>
+          <p:cNvPr id="23" name="TextBox 22"/>
           <p:cNvSpPr txBox="1"/>
           <p:nvPr/>
         </p:nvSpPr>
@@ -8471,6 +8999,66 @@
   <p:clrMapOvr>
     <a:masterClrMapping/>
   </p:clrMapOvr>
+  <p:timing>
+    <p:tnLst>
+      <p:par>
+        <p:cTn id="1" dur="indefinite" restart="never" nodeType="tmRoot">
+          <p:childTnLst>
+            <p:seq concurrent="1" nextAc="seek">
+              <p:cTn id="2" dur="indefinite" nodeType="mainSeq">
+                <p:childTnLst>
+                  <p:par>
+                    <p:cTn id="3" fill="hold">
+                      <p:stCondLst>
+                        <p:cond delay="0"/>
+                      </p:stCondLst>
+                      <p:childTnLst>
+                        <p:par>
+                          <p:cTn id="4" fill="hold">
+                            <p:stCondLst>
+                              <p:cond delay="0"/>
+                            </p:stCondLst>
+                            <p:childTnLst>
+                              <p:animMotion origin="layout" path="M 0 0 L 0.03 0.03" pathEditMode="relative" ptsTypes="AA" rAng="0">
+                                <p:cBhvr>
+                                  <p:cTn id="5" dur="8000" repeatCount="indefinite" autoRev="1" fill="hold">
+                                    <p:stCondLst>
+                                      <p:cond delay="0"/>
+                                    </p:stCondLst>
+                                  </p:cTn>
+                                  <p:tgtEl>
+                                    <p:spTgt spid="3"/>
+                                  </p:tgtEl>
+                                </p:cBhvr>
+                              </p:animMotion>
+                            </p:childTnLst>
+                          </p:cTn>
+                        </p:par>
+                      </p:childTnLst>
+                    </p:cTn>
+                  </p:par>
+                </p:childTnLst>
+              </p:cTn>
+              <p:prevCondLst>
+                <p:cond evt="onPrev" delay="0">
+                  <p:tgtEl>
+                    <p:sldTgt/>
+                  </p:tgtEl>
+                </p:cond>
+              </p:prevCondLst>
+              <p:nextCondLst>
+                <p:cond evt="onNext" delay="0">
+                  <p:tgtEl>
+                    <p:sldTgt/>
+                  </p:tgtEl>
+                </p:cond>
+              </p:nextCondLst>
+            </p:seq>
+          </p:childTnLst>
+        </p:cTn>
+      </p:par>
+    </p:tnLst>
+  </p:timing>
 </p:sld>
 </file>
 
@@ -8516,9 +9104,33 @@
           </a:prstGeom>
         </p:spPr>
       </p:pic>
-      <p:sp>
-        <p:nvSpPr>
-          <p:cNvPr id="3" name="TextBox 2"/>
+      <p:pic>
+        <p:nvPicPr>
+          <p:cNvPr id="3" name="Picture 2" descr="_slide_grid.png"/>
+          <p:cNvPicPr>
+            <a:picLocks noChangeAspect="1"/>
+          </p:cNvPicPr>
+          <p:nvPr/>
+        </p:nvPicPr>
+        <p:blipFill>
+          <a:blip r:embed="rId3"/>
+          <a:stretch>
+            <a:fillRect/>
+          </a:stretch>
+        </p:blipFill>
+        <p:spPr>
+          <a:xfrm>
+            <a:off x="-685800" y="-685800"/>
+            <a:ext cx="13563295" cy="8229600"/>
+          </a:xfrm>
+          <a:prstGeom prst="rect">
+            <a:avLst/>
+          </a:prstGeom>
+        </p:spPr>
+      </p:pic>
+      <p:sp>
+        <p:nvSpPr>
+          <p:cNvPr id="6" name="TextBox 5"/>
           <p:cNvSpPr txBox="1"/>
           <p:nvPr/>
         </p:nvSpPr>
@@ -8553,7 +9165,7 @@
       </p:sp>
       <p:sp>
         <p:nvSpPr>
-          <p:cNvPr id="4" name="TextBox 3"/>
+          <p:cNvPr id="7" name="TextBox 6"/>
           <p:cNvSpPr txBox="1"/>
           <p:nvPr/>
         </p:nvSpPr>
@@ -8588,7 +9200,7 @@
       </p:sp>
       <p:sp>
         <p:nvSpPr>
-          <p:cNvPr id="5" name="Rounded Rectangle 4"/>
+          <p:cNvPr id="8" name="Rounded Rectangle 7"/>
           <p:cNvSpPr/>
           <p:nvPr/>
         </p:nvSpPr>
@@ -8635,7 +9247,7 @@
       </p:sp>
       <p:sp>
         <p:nvSpPr>
-          <p:cNvPr id="6" name="Oval 5"/>
+          <p:cNvPr id="9" name="Oval 8"/>
           <p:cNvSpPr/>
           <p:nvPr/>
         </p:nvSpPr>
@@ -8678,7 +9290,7 @@
       </p:sp>
       <p:sp>
         <p:nvSpPr>
-          <p:cNvPr id="7" name="Oval 6"/>
+          <p:cNvPr id="10" name="Oval 9"/>
           <p:cNvSpPr/>
           <p:nvPr/>
         </p:nvSpPr>
@@ -8721,7 +9333,7 @@
       </p:sp>
       <p:sp>
         <p:nvSpPr>
-          <p:cNvPr id="8" name="Oval 7"/>
+          <p:cNvPr id="11" name="Oval 10"/>
           <p:cNvSpPr/>
           <p:nvPr/>
         </p:nvSpPr>
@@ -8764,7 +9376,7 @@
       </p:sp>
       <p:sp>
         <p:nvSpPr>
-          <p:cNvPr id="9" name="TextBox 8"/>
+          <p:cNvPr id="12" name="TextBox 11"/>
           <p:cNvSpPr txBox="1"/>
           <p:nvPr/>
         </p:nvSpPr>
@@ -8799,7 +9411,7 @@
       </p:sp>
       <p:sp>
         <p:nvSpPr>
-          <p:cNvPr id="10" name="TextBox 9"/>
+          <p:cNvPr id="13" name="TextBox 12"/>
           <p:cNvSpPr txBox="1"/>
           <p:nvPr/>
         </p:nvSpPr>
@@ -8841,7 +9453,7 @@
       </p:sp>
       <p:sp>
         <p:nvSpPr>
-          <p:cNvPr id="11" name="Rounded Rectangle 10"/>
+          <p:cNvPr id="14" name="Rounded Rectangle 13"/>
           <p:cNvSpPr/>
           <p:nvPr/>
         </p:nvSpPr>
@@ -8888,7 +9500,7 @@
       </p:sp>
       <p:sp>
         <p:nvSpPr>
-          <p:cNvPr id="12" name="TextBox 11"/>
+          <p:cNvPr id="15" name="TextBox 14"/>
           <p:cNvSpPr txBox="1"/>
           <p:nvPr/>
         </p:nvSpPr>
@@ -8923,7 +9535,7 @@
       </p:sp>
       <p:sp>
         <p:nvSpPr>
-          <p:cNvPr id="13" name="Oval 12"/>
+          <p:cNvPr id="16" name="Oval 15"/>
           <p:cNvSpPr/>
           <p:nvPr/>
         </p:nvSpPr>
@@ -8966,7 +9578,7 @@
       </p:sp>
       <p:sp>
         <p:nvSpPr>
-          <p:cNvPr id="14" name="TextBox 13"/>
+          <p:cNvPr id="17" name="TextBox 16"/>
           <p:cNvSpPr txBox="1"/>
           <p:nvPr/>
         </p:nvSpPr>
@@ -9001,7 +9613,7 @@
       </p:sp>
       <p:sp>
         <p:nvSpPr>
-          <p:cNvPr id="15" name="TextBox 14"/>
+          <p:cNvPr id="18" name="TextBox 17"/>
           <p:cNvSpPr txBox="1"/>
           <p:nvPr/>
         </p:nvSpPr>
@@ -9036,7 +9648,7 @@
       </p:sp>
       <p:sp>
         <p:nvSpPr>
-          <p:cNvPr id="16" name="Oval 15"/>
+          <p:cNvPr id="19" name="Oval 18"/>
           <p:cNvSpPr/>
           <p:nvPr/>
         </p:nvSpPr>
@@ -9079,7 +9691,7 @@
       </p:sp>
       <p:sp>
         <p:nvSpPr>
-          <p:cNvPr id="17" name="TextBox 16"/>
+          <p:cNvPr id="20" name="TextBox 19"/>
           <p:cNvSpPr txBox="1"/>
           <p:nvPr/>
         </p:nvSpPr>
@@ -9114,7 +9726,7 @@
       </p:sp>
       <p:sp>
         <p:nvSpPr>
-          <p:cNvPr id="18" name="TextBox 17"/>
+          <p:cNvPr id="21" name="TextBox 20"/>
           <p:cNvSpPr txBox="1"/>
           <p:nvPr/>
         </p:nvSpPr>
@@ -9149,7 +9761,7 @@
       </p:sp>
       <p:sp>
         <p:nvSpPr>
-          <p:cNvPr id="19" name="Oval 18"/>
+          <p:cNvPr id="22" name="Oval 21"/>
           <p:cNvSpPr/>
           <p:nvPr/>
         </p:nvSpPr>
@@ -9192,7 +9804,7 @@
       </p:sp>
       <p:sp>
         <p:nvSpPr>
-          <p:cNvPr id="20" name="TextBox 19"/>
+          <p:cNvPr id="23" name="TextBox 22"/>
           <p:cNvSpPr txBox="1"/>
           <p:nvPr/>
         </p:nvSpPr>
@@ -9227,7 +9839,7 @@
       </p:sp>
       <p:sp>
         <p:nvSpPr>
-          <p:cNvPr id="21" name="TextBox 20"/>
+          <p:cNvPr id="24" name="TextBox 23"/>
           <p:cNvSpPr txBox="1"/>
           <p:nvPr/>
         </p:nvSpPr>
@@ -9262,7 +9874,7 @@
       </p:sp>
       <p:sp>
         <p:nvSpPr>
-          <p:cNvPr id="22" name="Oval 21"/>
+          <p:cNvPr id="25" name="Oval 24"/>
           <p:cNvSpPr/>
           <p:nvPr/>
         </p:nvSpPr>
@@ -9305,7 +9917,7 @@
       </p:sp>
       <p:sp>
         <p:nvSpPr>
-          <p:cNvPr id="23" name="TextBox 22"/>
+          <p:cNvPr id="26" name="TextBox 25"/>
           <p:cNvSpPr txBox="1"/>
           <p:nvPr/>
         </p:nvSpPr>
@@ -9340,7 +9952,7 @@
       </p:sp>
       <p:sp>
         <p:nvSpPr>
-          <p:cNvPr id="24" name="TextBox 23"/>
+          <p:cNvPr id="27" name="TextBox 26"/>
           <p:cNvSpPr txBox="1"/>
           <p:nvPr/>
         </p:nvSpPr>
@@ -9378,6 +9990,66 @@
   <p:clrMapOvr>
     <a:masterClrMapping/>
   </p:clrMapOvr>
+  <p:timing>
+    <p:tnLst>
+      <p:par>
+        <p:cTn id="1" dur="indefinite" restart="never" nodeType="tmRoot">
+          <p:childTnLst>
+            <p:seq concurrent="1" nextAc="seek">
+              <p:cTn id="2" dur="indefinite" nodeType="mainSeq">
+                <p:childTnLst>
+                  <p:par>
+                    <p:cTn id="3" fill="hold">
+                      <p:stCondLst>
+                        <p:cond delay="0"/>
+                      </p:stCondLst>
+                      <p:childTnLst>
+                        <p:par>
+                          <p:cTn id="4" fill="hold">
+                            <p:stCondLst>
+                              <p:cond delay="0"/>
+                            </p:stCondLst>
+                            <p:childTnLst>
+                              <p:animMotion origin="layout" path="M 0 0 L 0.03 0.03" pathEditMode="relative" ptsTypes="AA" rAng="0">
+                                <p:cBhvr>
+                                  <p:cTn id="5" dur="8000" repeatCount="indefinite" autoRev="1" fill="hold">
+                                    <p:stCondLst>
+                                      <p:cond delay="0"/>
+                                    </p:stCondLst>
+                                  </p:cTn>
+                                  <p:tgtEl>
+                                    <p:spTgt spid="3"/>
+                                  </p:tgtEl>
+                                </p:cBhvr>
+                              </p:animMotion>
+                            </p:childTnLst>
+                          </p:cTn>
+                        </p:par>
+                      </p:childTnLst>
+                    </p:cTn>
+                  </p:par>
+                </p:childTnLst>
+              </p:cTn>
+              <p:prevCondLst>
+                <p:cond evt="onPrev" delay="0">
+                  <p:tgtEl>
+                    <p:sldTgt/>
+                  </p:tgtEl>
+                </p:cond>
+              </p:prevCondLst>
+              <p:nextCondLst>
+                <p:cond evt="onNext" delay="0">
+                  <p:tgtEl>
+                    <p:sldTgt/>
+                  </p:tgtEl>
+                </p:cond>
+              </p:nextCondLst>
+            </p:seq>
+          </p:childTnLst>
+        </p:cTn>
+      </p:par>
+    </p:tnLst>
+  </p:timing>
 </p:sld>
 </file>
 
@@ -9423,9 +10095,33 @@
           </a:prstGeom>
         </p:spPr>
       </p:pic>
-      <p:sp>
-        <p:nvSpPr>
-          <p:cNvPr id="3" name="TextBox 2"/>
+      <p:pic>
+        <p:nvPicPr>
+          <p:cNvPr id="3" name="Picture 2" descr="_slide_grid.png"/>
+          <p:cNvPicPr>
+            <a:picLocks noChangeAspect="1"/>
+          </p:cNvPicPr>
+          <p:nvPr/>
+        </p:nvPicPr>
+        <p:blipFill>
+          <a:blip r:embed="rId3"/>
+          <a:stretch>
+            <a:fillRect/>
+          </a:stretch>
+        </p:blipFill>
+        <p:spPr>
+          <a:xfrm>
+            <a:off x="-685800" y="-685800"/>
+            <a:ext cx="13563295" cy="8229600"/>
+          </a:xfrm>
+          <a:prstGeom prst="rect">
+            <a:avLst/>
+          </a:prstGeom>
+        </p:spPr>
+      </p:pic>
+      <p:sp>
+        <p:nvSpPr>
+          <p:cNvPr id="6" name="TextBox 5"/>
           <p:cNvSpPr txBox="1"/>
           <p:nvPr/>
         </p:nvSpPr>
@@ -9460,7 +10156,7 @@
       </p:sp>
       <p:sp>
         <p:nvSpPr>
-          <p:cNvPr id="4" name="TextBox 3"/>
+          <p:cNvPr id="7" name="TextBox 6"/>
           <p:cNvSpPr txBox="1"/>
           <p:nvPr/>
         </p:nvSpPr>
@@ -9495,7 +10191,7 @@
       </p:sp>
       <p:sp>
         <p:nvSpPr>
-          <p:cNvPr id="5" name="TextBox 4"/>
+          <p:cNvPr id="8" name="TextBox 7"/>
           <p:cNvSpPr txBox="1"/>
           <p:nvPr/>
         </p:nvSpPr>
@@ -9530,7 +10226,7 @@
       </p:sp>
       <p:sp>
         <p:nvSpPr>
-          <p:cNvPr id="6" name="TextBox 5"/>
+          <p:cNvPr id="9" name="TextBox 8"/>
           <p:cNvSpPr txBox="1"/>
           <p:nvPr/>
         </p:nvSpPr>
@@ -9565,7 +10261,7 @@
       </p:sp>
       <p:sp>
         <p:nvSpPr>
-          <p:cNvPr id="7" name="Rounded Rectangle 6"/>
+          <p:cNvPr id="10" name="Rounded Rectangle 9"/>
           <p:cNvSpPr/>
           <p:nvPr/>
         </p:nvSpPr>
@@ -9610,7 +10306,7 @@
       </p:sp>
       <p:sp>
         <p:nvSpPr>
-          <p:cNvPr id="8" name="Rounded Rectangle 7"/>
+          <p:cNvPr id="11" name="Rounded Rectangle 10"/>
           <p:cNvSpPr/>
           <p:nvPr/>
         </p:nvSpPr>
@@ -9655,7 +10351,7 @@
       </p:sp>
       <p:sp>
         <p:nvSpPr>
-          <p:cNvPr id="9" name="TextBox 8"/>
+          <p:cNvPr id="12" name="TextBox 11"/>
           <p:cNvSpPr txBox="1"/>
           <p:nvPr/>
         </p:nvSpPr>
@@ -9690,7 +10386,7 @@
       </p:sp>
       <p:sp>
         <p:nvSpPr>
-          <p:cNvPr id="10" name="Rounded Rectangle 9"/>
+          <p:cNvPr id="13" name="Rounded Rectangle 12"/>
           <p:cNvSpPr/>
           <p:nvPr/>
         </p:nvSpPr>
@@ -9744,7 +10440,7 @@
       </p:sp>
       <p:sp>
         <p:nvSpPr>
-          <p:cNvPr id="11" name="Rounded Rectangle 10"/>
+          <p:cNvPr id="14" name="Rounded Rectangle 13"/>
           <p:cNvSpPr/>
           <p:nvPr/>
         </p:nvSpPr>
@@ -9798,7 +10494,7 @@
       </p:sp>
       <p:sp>
         <p:nvSpPr>
-          <p:cNvPr id="12" name="Rounded Rectangle 11"/>
+          <p:cNvPr id="15" name="Rounded Rectangle 14"/>
           <p:cNvSpPr/>
           <p:nvPr/>
         </p:nvSpPr>
@@ -9852,7 +10548,7 @@
       </p:sp>
       <p:sp>
         <p:nvSpPr>
-          <p:cNvPr id="13" name="Rounded Rectangle 12"/>
+          <p:cNvPr id="16" name="Rounded Rectangle 15"/>
           <p:cNvSpPr/>
           <p:nvPr/>
         </p:nvSpPr>
@@ -9906,7 +10602,7 @@
       </p:sp>
       <p:sp>
         <p:nvSpPr>
-          <p:cNvPr id="14" name="TextBox 13"/>
+          <p:cNvPr id="17" name="TextBox 16"/>
           <p:cNvSpPr txBox="1"/>
           <p:nvPr/>
         </p:nvSpPr>
@@ -9941,7 +10637,7 @@
       </p:sp>
       <p:sp>
         <p:nvSpPr>
-          <p:cNvPr id="15" name="TextBox 14"/>
+          <p:cNvPr id="18" name="TextBox 17"/>
           <p:cNvSpPr txBox="1"/>
           <p:nvPr/>
         </p:nvSpPr>
@@ -9979,6 +10675,66 @@
   <p:clrMapOvr>
     <a:masterClrMapping/>
   </p:clrMapOvr>
+  <p:timing>
+    <p:tnLst>
+      <p:par>
+        <p:cTn id="1" dur="indefinite" restart="never" nodeType="tmRoot">
+          <p:childTnLst>
+            <p:seq concurrent="1" nextAc="seek">
+              <p:cTn id="2" dur="indefinite" nodeType="mainSeq">
+                <p:childTnLst>
+                  <p:par>
+                    <p:cTn id="3" fill="hold">
+                      <p:stCondLst>
+                        <p:cond delay="0"/>
+                      </p:stCondLst>
+                      <p:childTnLst>
+                        <p:par>
+                          <p:cTn id="4" fill="hold">
+                            <p:stCondLst>
+                              <p:cond delay="0"/>
+                            </p:stCondLst>
+                            <p:childTnLst>
+                              <p:animMotion origin="layout" path="M 0 0 L 0.03 0.03" pathEditMode="relative" ptsTypes="AA" rAng="0">
+                                <p:cBhvr>
+                                  <p:cTn id="5" dur="8000" repeatCount="indefinite" autoRev="1" fill="hold">
+                                    <p:stCondLst>
+                                      <p:cond delay="0"/>
+                                    </p:stCondLst>
+                                  </p:cTn>
+                                  <p:tgtEl>
+                                    <p:spTgt spid="3"/>
+                                  </p:tgtEl>
+                                </p:cBhvr>
+                              </p:animMotion>
+                            </p:childTnLst>
+                          </p:cTn>
+                        </p:par>
+                      </p:childTnLst>
+                    </p:cTn>
+                  </p:par>
+                </p:childTnLst>
+              </p:cTn>
+              <p:prevCondLst>
+                <p:cond evt="onPrev" delay="0">
+                  <p:tgtEl>
+                    <p:sldTgt/>
+                  </p:tgtEl>
+                </p:cond>
+              </p:prevCondLst>
+              <p:nextCondLst>
+                <p:cond evt="onNext" delay="0">
+                  <p:tgtEl>
+                    <p:sldTgt/>
+                  </p:tgtEl>
+                </p:cond>
+              </p:nextCondLst>
+            </p:seq>
+          </p:childTnLst>
+        </p:cTn>
+      </p:par>
+    </p:tnLst>
+  </p:timing>
 </p:sld>
 </file>
 
@@ -10024,9 +10780,33 @@
           </a:prstGeom>
         </p:spPr>
       </p:pic>
-      <p:sp>
-        <p:nvSpPr>
-          <p:cNvPr id="3" name="TextBox 2"/>
+      <p:pic>
+        <p:nvPicPr>
+          <p:cNvPr id="3" name="Picture 2" descr="_slide_grid.png"/>
+          <p:cNvPicPr>
+            <a:picLocks noChangeAspect="1"/>
+          </p:cNvPicPr>
+          <p:nvPr/>
+        </p:nvPicPr>
+        <p:blipFill>
+          <a:blip r:embed="rId3"/>
+          <a:stretch>
+            <a:fillRect/>
+          </a:stretch>
+        </p:blipFill>
+        <p:spPr>
+          <a:xfrm>
+            <a:off x="-685800" y="-685800"/>
+            <a:ext cx="13563295" cy="8229600"/>
+          </a:xfrm>
+          <a:prstGeom prst="rect">
+            <a:avLst/>
+          </a:prstGeom>
+        </p:spPr>
+      </p:pic>
+      <p:sp>
+        <p:nvSpPr>
+          <p:cNvPr id="6" name="TextBox 5"/>
           <p:cNvSpPr txBox="1"/>
           <p:nvPr/>
         </p:nvSpPr>
@@ -10061,7 +10841,7 @@
       </p:sp>
       <p:sp>
         <p:nvSpPr>
-          <p:cNvPr id="4" name="TextBox 3"/>
+          <p:cNvPr id="7" name="TextBox 6"/>
           <p:cNvSpPr txBox="1"/>
           <p:nvPr/>
         </p:nvSpPr>
@@ -10096,7 +10876,7 @@
       </p:sp>
       <p:sp>
         <p:nvSpPr>
-          <p:cNvPr id="5" name="TextBox 4"/>
+          <p:cNvPr id="8" name="TextBox 7"/>
           <p:cNvSpPr txBox="1"/>
           <p:nvPr/>
         </p:nvSpPr>
@@ -10131,7 +10911,7 @@
       </p:sp>
       <p:sp>
         <p:nvSpPr>
-          <p:cNvPr id="6" name="TextBox 5"/>
+          <p:cNvPr id="9" name="TextBox 8"/>
           <p:cNvSpPr txBox="1"/>
           <p:nvPr/>
         </p:nvSpPr>
@@ -10166,7 +10946,7 @@
       </p:sp>
       <p:sp>
         <p:nvSpPr>
-          <p:cNvPr id="7" name="TextBox 6"/>
+          <p:cNvPr id="10" name="TextBox 9"/>
           <p:cNvSpPr txBox="1"/>
           <p:nvPr/>
         </p:nvSpPr>
@@ -10201,7 +10981,7 @@
       </p:sp>
       <p:sp>
         <p:nvSpPr>
-          <p:cNvPr id="8" name="TextBox 7"/>
+          <p:cNvPr id="11" name="TextBox 10"/>
           <p:cNvSpPr txBox="1"/>
           <p:nvPr/>
         </p:nvSpPr>
@@ -10236,7 +11016,7 @@
       </p:sp>
       <p:sp>
         <p:nvSpPr>
-          <p:cNvPr id="9" name="TextBox 8"/>
+          <p:cNvPr id="12" name="TextBox 11"/>
           <p:cNvSpPr txBox="1"/>
           <p:nvPr/>
         </p:nvSpPr>
@@ -10271,7 +11051,7 @@
       </p:sp>
       <p:sp>
         <p:nvSpPr>
-          <p:cNvPr id="10" name="TextBox 9"/>
+          <p:cNvPr id="13" name="TextBox 12"/>
           <p:cNvSpPr txBox="1"/>
           <p:nvPr/>
         </p:nvSpPr>
@@ -10306,7 +11086,7 @@
       </p:sp>
       <p:sp>
         <p:nvSpPr>
-          <p:cNvPr id="11" name="TextBox 10"/>
+          <p:cNvPr id="14" name="TextBox 13"/>
           <p:cNvSpPr txBox="1"/>
           <p:nvPr/>
         </p:nvSpPr>
@@ -10341,7 +11121,7 @@
       </p:sp>
       <p:sp>
         <p:nvSpPr>
-          <p:cNvPr id="12" name="TextBox 11"/>
+          <p:cNvPr id="15" name="TextBox 14"/>
           <p:cNvSpPr txBox="1"/>
           <p:nvPr/>
         </p:nvSpPr>
@@ -10376,7 +11156,7 @@
       </p:sp>
       <p:sp>
         <p:nvSpPr>
-          <p:cNvPr id="13" name="TextBox 12"/>
+          <p:cNvPr id="16" name="TextBox 15"/>
           <p:cNvSpPr txBox="1"/>
           <p:nvPr/>
         </p:nvSpPr>
@@ -10411,7 +11191,7 @@
       </p:sp>
       <p:sp>
         <p:nvSpPr>
-          <p:cNvPr id="14" name="TextBox 13"/>
+          <p:cNvPr id="17" name="TextBox 16"/>
           <p:cNvSpPr txBox="1"/>
           <p:nvPr/>
         </p:nvSpPr>
@@ -10446,7 +11226,7 @@
       </p:sp>
       <p:sp>
         <p:nvSpPr>
-          <p:cNvPr id="15" name="TextBox 14"/>
+          <p:cNvPr id="18" name="TextBox 17"/>
           <p:cNvSpPr txBox="1"/>
           <p:nvPr/>
         </p:nvSpPr>
@@ -10484,6 +11264,66 @@
   <p:clrMapOvr>
     <a:masterClrMapping/>
   </p:clrMapOvr>
+  <p:timing>
+    <p:tnLst>
+      <p:par>
+        <p:cTn id="1" dur="indefinite" restart="never" nodeType="tmRoot">
+          <p:childTnLst>
+            <p:seq concurrent="1" nextAc="seek">
+              <p:cTn id="2" dur="indefinite" nodeType="mainSeq">
+                <p:childTnLst>
+                  <p:par>
+                    <p:cTn id="3" fill="hold">
+                      <p:stCondLst>
+                        <p:cond delay="0"/>
+                      </p:stCondLst>
+                      <p:childTnLst>
+                        <p:par>
+                          <p:cTn id="4" fill="hold">
+                            <p:stCondLst>
+                              <p:cond delay="0"/>
+                            </p:stCondLst>
+                            <p:childTnLst>
+                              <p:animMotion origin="layout" path="M 0 0 L 0.03 0.03" pathEditMode="relative" ptsTypes="AA" rAng="0">
+                                <p:cBhvr>
+                                  <p:cTn id="5" dur="8000" repeatCount="indefinite" autoRev="1" fill="hold">
+                                    <p:stCondLst>
+                                      <p:cond delay="0"/>
+                                    </p:stCondLst>
+                                  </p:cTn>
+                                  <p:tgtEl>
+                                    <p:spTgt spid="3"/>
+                                  </p:tgtEl>
+                                </p:cBhvr>
+                              </p:animMotion>
+                            </p:childTnLst>
+                          </p:cTn>
+                        </p:par>
+                      </p:childTnLst>
+                    </p:cTn>
+                  </p:par>
+                </p:childTnLst>
+              </p:cTn>
+              <p:prevCondLst>
+                <p:cond evt="onPrev" delay="0">
+                  <p:tgtEl>
+                    <p:sldTgt/>
+                  </p:tgtEl>
+                </p:cond>
+              </p:prevCondLst>
+              <p:nextCondLst>
+                <p:cond evt="onNext" delay="0">
+                  <p:tgtEl>
+                    <p:sldTgt/>
+                  </p:tgtEl>
+                </p:cond>
+              </p:nextCondLst>
+            </p:seq>
+          </p:childTnLst>
+        </p:cTn>
+      </p:par>
+    </p:tnLst>
+  </p:timing>
 </p:sld>
 </file>
 

</xml_diff>